<commit_message>
feat(epod): lock e-POD signing during transit, require manual QC verification for delivery, and update prep docs
</commit_message>
<xml_diff>
--- a/prep/TrackPoint_Master_Presentation.pptx
+++ b/prep/TrackPoint_Master_Presentation.pptx
@@ -5534,7 +5534,7 @@
               </a:defRPr>
             </a:pPr>
             <a:r>
-              <a:t>Vehicle departs Darwin depot. Live telematics stream vector coordinates, bearing, and speed (92 km/h) down the corridor.</a:t>
+              <a:t>Vehicle journeys down corridor. e-POD pad is strictly LOCKED with transit warning banner to prevent fraudulent en-route sign-offs.</a:t>
             </a:r>
           </a:p>
         </p:txBody>
@@ -5644,7 +5644,7 @@
               </a:defRPr>
             </a:pPr>
             <a:r>
-              <a:t>Truck docks at destination dock (0 km/h). CRITICAL: Delivery is blocked until physical QC inspection and e-POD are signed.</a:t>
+              <a:t>Truck docks at receiving bay (0 km/h) or driver marks arrival. Unlocks dock QC inspection gate. Premature auto-delivery is blocked.</a:t>
             </a:r>
           </a:p>
         </p:txBody>
@@ -5739,7 +5739,7 @@
               </a:defRPr>
             </a:pPr>
             <a:r>
-              <a:t>Verified &amp; Closed</a:t>
+              <a:t>Manual Sign-Off</a:t>
             </a:r>
           </a:p>
           <a:p>
@@ -5754,7 +5754,7 @@
               </a:defRPr>
             </a:pPr>
             <a:r>
-              <a:t>Bolt seal verified (#NT-89422-SEC), reefer temp checked (+4°C), consignee digital sign-off completed. Invoice auto-issued.</a:t>
+              <a:t>Authorized supervisor conducts physical QC, confirms bolt seal &amp; reefer temp, signs e-POD, and manually sets status to Delivered.</a:t>
             </a:r>
           </a:p>
         </p:txBody>
@@ -5978,7 +5978,7 @@
               </a:defRPr>
             </a:pPr>
             <a:r>
-              <a:t>✔ Real-World Depth: In commercial logistics, cargo can never be marked 'Delivered' automatically upon arrival.</a:t>
+              <a:t>✔ Transit Lockout Enforcement: Driver handset explicitly disables e-POD signature during transit with an active warning banner, preventing fraudulent drop-off claims.</a:t>
             </a:r>
           </a:p>
           <a:p>
@@ -5993,7 +5993,7 @@
               </a:defRPr>
             </a:pPr>
             <a:r>
-              <a:t>✔ CoR Statutory Compliance: The receiver and carrier are legally liable under Australian law for cargo security and temperature compliance.</a:t>
+              <a:t>✔ Segregation of Duties (SoD): In real enterprise freight, a truck cannot auto-mark 'Delivered'. Proximity only sets 'Arrived'—a human inspector must manually sign off QC.</a:t>
             </a:r>
           </a:p>
           <a:p>
@@ -6008,7 +6008,7 @@
               </a:defRPr>
             </a:pPr>
             <a:r>
-              <a:t>✔ Prevents Multi-Million Dollar Claims: If a container bolt seal is tampered with or frozen beef spoils above +4°C, TrackPoint flags it immediately before custody transfers.</a:t>
+              <a:t>✔ CoR Statutory Compliance: The receiver and carrier are legally liable under Australian law for cargo security (#NT-89422-SEC bolt seal) and temperature compliance (+4°C).</a:t>
             </a:r>
           </a:p>
           <a:p>
@@ -6023,7 +6023,7 @@
               </a:defRPr>
             </a:pPr>
             <a:r>
-              <a:t>✔ Zero Paper Dockets: Receiver digitally signs on tablet/screen. Legal e-POD is permanently archived with UTC/ACST timestamps.</a:t>
+              <a:t>✔ Manual Audit Gate: Dispatcher/supervisor verifies seal, checks reefer cold-chain, signs digital e-POD, and manually transitions status to Delivered, immediately releasing the tax invoice.</a:t>
             </a:r>
           </a:p>
         </p:txBody>

</xml_diff>